<commit_message>
feat: add presentation figures figH-figJ and presentation flow doc
- figH: NHANES AUC-PR lift (RA + Psoriasis)
- figI_ra_formula: annotated RA M4 formula with MCV/RDW/HGB biological labels
- figI_signal_travels: merged EHRSHOT + NHANES lift ("The Signal Travels" slide)
- figJ_matched_lr: formula vs same-feature LR scatter (preempts matched-LR reviewer question; T2D excluded for scale)
- docs/presentation_flow.md: full slide-by-slide narrative doc with figure index and open items
- Slide 5 talking point: matched-LR benchmark added to presentation_flow.md
- Updated EHRSHOT eval CSVs, method3_gp master summaries, methods_comparison.csv

Co-Authored-By: Claude Sonnet 4.6 <noreply@anthropic.com>
</commit_message>
<xml_diff>
--- a/docs/Can-a-Routine-CBC-Predict-Chronic-Disease_v2.pptx
+++ b/docs/Can-a-Routine-CBC-Predict-Chronic-Disease_v2.pptx
@@ -16,6 +16,7 @@
     <p:sldId id="261" r:id="rId6"/>
     <p:sldId id="273" r:id="rId7"/>
     <p:sldId id="275" r:id="rId19"/>
+    <p:sldId id="276" r:id="rId20"/>
     <p:sldId id="264" r:id="rId8"/>
     <p:sldId id="265" r:id="rId9"/>
   </p:sldIdLst>
@@ -1691,7 +1692,7 @@
                 </a:solidFill>
                 <a:latin typeface="Calibri"/>
               </a:rPr>
-              <a:t>Lift = AUC-PR / prevalence. Values &gt; 1 mean the formula outperforms random flagging at the disease’s base rate.</a:t>
+              <a:t>Lift = AUC-PR / prevalence. Values &gt; 1 mean the formula outperforms random flagging. Y-axis capped at 8× (M2 Lupus = 11.36×, M2 Psoriasis = 7.02×).</a:t>
             </a:r>
           </a:p>
         </p:txBody>
@@ -1712,8 +1713,8 @@
         </p:blipFill>
         <p:spPr>
           <a:xfrm>
-            <a:off x="274320" y="1143000"/>
-            <a:ext cx="11612880" cy="5120640"/>
+            <a:off x="182880" y="1097280"/>
+            <a:ext cx="11887200" cy="5212080"/>
           </a:xfrm>
           <a:prstGeom prst="rect">
             <a:avLst/>
@@ -1750,7 +1751,154 @@
                 </a:solidFill>
                 <a:latin typeface="Calibri"/>
               </a:rPr>
-              <a:t>B1 = Threshold baseline (M1). M3-GP highlighted in green. T2D shows markedly higher absolute lift due to higher CBC-disease correlation.</a:t>
+              <a:t>B1 = single-feature threshold baseline. M5 (dark green) = Seeded GP using LLM-generated formula seeds. T2D has no M5 (seeding not applied). M2’s high MIMIC lift on lup/psr reflects feature count overfitting — see next slide.</a:t>
+            </a:r>
+          </a:p>
+        </p:txBody>
+      </p:sp>
+    </p:spTree>
+  </p:cSld>
+  <p:clrMapOvr>
+    <a:masterClrMapping/>
+  </p:clrMapOvr>
+</p:sld>
+</file>
+
+<file path=ppt/slides/slide11.xml><?xml version="1.0" encoding="utf-8"?>
+<p:sld xmlns:a="http://schemas.openxmlformats.org/drawingml/2006/main" xmlns:p="http://schemas.openxmlformats.org/presentationml/2006/main" xmlns:r="http://schemas.openxmlformats.org/officeDocument/2006/relationships">
+  <p:cSld>
+    <p:spTree>
+      <p:nvGrpSpPr>
+        <p:cNvPr id="1" name=""/>
+        <p:cNvGrpSpPr/>
+        <p:nvPr/>
+      </p:nvGrpSpPr>
+      <p:grpSpPr/>
+      <p:sp>
+        <p:nvSpPr>
+          <p:cNvPr id="2" name="TextBox 1"/>
+          <p:cNvSpPr txBox="1"/>
+          <p:nvPr/>
+        </p:nvSpPr>
+        <p:spPr>
+          <a:xfrm>
+            <a:off x="457200" y="228600"/>
+            <a:ext cx="11247120" cy="502920"/>
+          </a:xfrm>
+          <a:prstGeom prst="rect">
+            <a:avLst/>
+          </a:prstGeom>
+          <a:noFill/>
+        </p:spPr>
+        <p:txBody>
+          <a:bodyPr wrap="square">
+            <a:spAutoFit/>
+          </a:bodyPr>
+          <a:lstStyle/>
+          <a:p>
+            <a:pPr algn="l"/>
+            <a:r>
+              <a:rPr sz="2200" b="1" i="0">
+                <a:solidFill>
+                  <a:srgbClr val="1F397D"/>
+                </a:solidFill>
+                <a:latin typeface="Calibri"/>
+              </a:rPr>
+              <a:t>Why M5? M2 Overfits — M5 Generalises</a:t>
+            </a:r>
+          </a:p>
+        </p:txBody>
+      </p:sp>
+      <p:sp>
+        <p:nvSpPr>
+          <p:cNvPr id="3" name="TextBox 2"/>
+          <p:cNvSpPr txBox="1"/>
+          <p:nvPr/>
+        </p:nvSpPr>
+        <p:spPr>
+          <a:xfrm>
+            <a:off x="457200" y="758952"/>
+            <a:ext cx="11247120" cy="274320"/>
+          </a:xfrm>
+          <a:prstGeom prst="rect">
+            <a:avLst/>
+          </a:prstGeom>
+          <a:noFill/>
+        </p:spPr>
+        <p:txBody>
+          <a:bodyPr wrap="square">
+            <a:spAutoFit/>
+          </a:bodyPr>
+          <a:lstStyle/>
+          <a:p>
+            <a:pPr algn="l"/>
+            <a:r>
+              <a:rPr sz="1000" b="0" i="1">
+                <a:solidFill>
+                  <a:srgbClr val="555555"/>
+                </a:solidFill>
+                <a:latin typeface="Calibri"/>
+              </a:rPr>
+              <a:t>M2 (Random Search) uses 4–13 features and achieves very high MIMIC test-set lift. On EHRSHOT (unseen Stanford data) that advantage nearly vanishes. M5 (Seeded GP, 3–6 features) is more consistent across both datasets.</a:t>
+            </a:r>
+          </a:p>
+        </p:txBody>
+      </p:sp>
+      <p:pic>
+        <p:nvPicPr>
+          <p:cNvPr id="4" name="Picture 3" descr="image.png"/>
+          <p:cNvPicPr>
+            <a:picLocks noChangeAspect="1"/>
+          </p:cNvPicPr>
+          <p:nvPr/>
+        </p:nvPicPr>
+        <p:blipFill>
+          <a:blip r:embed="rId2"/>
+          <a:stretch>
+            <a:fillRect/>
+          </a:stretch>
+        </p:blipFill>
+        <p:spPr>
+          <a:xfrm>
+            <a:off x="182880" y="1097280"/>
+            <a:ext cx="11887200" cy="5029200"/>
+          </a:xfrm>
+          <a:prstGeom prst="rect">
+            <a:avLst/>
+          </a:prstGeom>
+        </p:spPr>
+      </p:pic>
+      <p:sp>
+        <p:nvSpPr>
+          <p:cNvPr id="5" name="TextBox 4"/>
+          <p:cNvSpPr txBox="1"/>
+          <p:nvPr/>
+        </p:nvSpPr>
+        <p:spPr>
+          <a:xfrm>
+            <a:off x="457200" y="6217920"/>
+            <a:ext cx="11247120" cy="365760"/>
+          </a:xfrm>
+          <a:prstGeom prst="rect">
+            <a:avLst/>
+          </a:prstGeom>
+          <a:noFill/>
+        </p:spPr>
+        <p:txBody>
+          <a:bodyPr wrap="square">
+            <a:spAutoFit/>
+          </a:bodyPr>
+          <a:lstStyle/>
+          <a:p>
+            <a:pPr algn="l"/>
+            <a:r>
+              <a:rPr sz="900" b="0" i="1">
+                <a:solidFill>
+                  <a:srgbClr val="555555"/>
+                </a:solidFill>
+                <a:latin typeface="Calibri"/>
+              </a:rPr>
+              <a:t>Features used:  RA: M2=9, M5=4   |   Crohn: M2=13, M5=4   |   T1D: M2=6, M5=9   |   Psoriasis: M2=4, M5=3   |   Lupus: M2=8, M5=6</a:t>
             </a:r>
           </a:p>
         </p:txBody>
@@ -11971,7 +12119,7 @@
                 </a:solidFill>
                 <a:latin typeface="Calibri"/>
               </a:rPr>
-              <a:t>EHRSHOT (Stanford) — AUC-PR Lift (lift = AUC-PR / cohort prevalence)</a:t>
+              <a:t>EHRSHOT (Stanford EHR) — AUC-PR Lift  (lift = AUC-PR / cohort prevalence)</a:t>
             </a:r>
           </a:p>
         </p:txBody>
@@ -11992,8 +12140,8 @@
         </p:blipFill>
         <p:spPr>
           <a:xfrm>
-            <a:off x="457200" y="1737360"/>
-            <a:ext cx="11247120" cy="3931920"/>
+            <a:off x="274320" y="1737360"/>
+            <a:ext cx="11612880" cy="3931920"/>
           </a:xfrm>
           <a:prstGeom prst="rect">
             <a:avLst/>

</xml_diff>